<commit_message>
Include smoother replay results in slides
</commit_message>
<xml_diff>
--- a/docs/foul_detection_presentation.pptx
+++ b/docs/foul_detection_presentation.pptx
@@ -16,6 +16,8 @@
     <p:sldId id="264" r:id="rId15"/>
     <p:sldId id="265" r:id="rId16"/>
     <p:sldId id="266" r:id="rId17"/>
+    <p:sldId id="267" r:id="rId18"/>
+    <p:sldId id="268" r:id="rId19"/>
   </p:sldIdLst>
   <p:sldSz cx="12191695" cy="6858000" type="screen4x3"/>
   <p:notesSz cx="6858000" cy="9144000"/>
@@ -4349,6 +4351,1642 @@
             </a:pPr>
             <a:r>
               <a:t>11</a:t>
+            </a:r>
+          </a:p>
+        </p:txBody>
+      </p:sp>
+    </p:spTree>
+  </p:cSld>
+  <p:clrMapOvr>
+    <a:masterClrMapping/>
+  </p:clrMapOvr>
+</p:sld>
+</file>
+
+<file path=ppt/slides/slide12.xml><?xml version="1.0" encoding="utf-8"?>
+<p:sld xmlns:a="http://schemas.openxmlformats.org/drawingml/2006/main" xmlns:p="http://schemas.openxmlformats.org/presentationml/2006/main" xmlns:r="http://schemas.openxmlformats.org/officeDocument/2006/relationships">
+  <p:cSld>
+    <p:bg>
+      <p:bgPr>
+        <a:solidFill>
+          <a:srgbClr val="F6F7F3"/>
+        </a:solidFill>
+        <a:effectLst/>
+      </p:bgPr>
+    </p:bg>
+    <p:spTree>
+      <p:nvGrpSpPr>
+        <p:cNvPr id="1" name=""/>
+        <p:cNvGrpSpPr/>
+        <p:nvPr/>
+      </p:nvGrpSpPr>
+      <p:grpSpPr/>
+      <p:sp>
+        <p:nvSpPr>
+          <p:cNvPr id="2" name="Rectangle 1"/>
+          <p:cNvSpPr/>
+          <p:nvPr/>
+        </p:nvSpPr>
+        <p:spPr>
+          <a:xfrm>
+            <a:off x="0" y="0"/>
+            <a:ext cx="164592" cy="6858000"/>
+          </a:xfrm>
+          <a:prstGeom prst="rect">
+            <a:avLst/>
+          </a:prstGeom>
+          <a:solidFill>
+            <a:srgbClr val="C2272D"/>
+          </a:solidFill>
+          <a:ln>
+            <a:solidFill>
+              <a:srgbClr val="C2272D"/>
+            </a:solidFill>
+          </a:ln>
+        </p:spPr>
+        <p:style>
+          <a:lnRef idx="1">
+            <a:schemeClr val="accent1"/>
+          </a:lnRef>
+          <a:fillRef idx="3">
+            <a:schemeClr val="accent1"/>
+          </a:fillRef>
+          <a:effectRef idx="2">
+            <a:schemeClr val="accent1"/>
+          </a:effectRef>
+          <a:fontRef idx="minor">
+            <a:schemeClr val="lt1"/>
+          </a:fontRef>
+        </p:style>
+        <p:txBody>
+          <a:bodyPr rtlCol="0" anchor="ctr"/>
+          <a:lstStyle/>
+          <a:p>
+            <a:pPr algn="ctr"/>
+          </a:p>
+        </p:txBody>
+      </p:sp>
+      <p:sp>
+        <p:nvSpPr>
+          <p:cNvPr id="3" name="TextBox 2"/>
+          <p:cNvSpPr txBox="1"/>
+          <p:nvPr/>
+        </p:nvSpPr>
+        <p:spPr>
+          <a:xfrm>
+            <a:off x="502920" y="320040"/>
+            <a:ext cx="10972800" cy="658368"/>
+          </a:xfrm>
+          <a:prstGeom prst="rect">
+            <a:avLst/>
+          </a:prstGeom>
+          <a:noFill/>
+        </p:spPr>
+        <p:txBody>
+          <a:bodyPr wrap="square" lIns="18288" rIns="18288">
+            <a:spAutoFit/>
+          </a:bodyPr>
+          <a:lstStyle/>
+          <a:p>
+            <a:pPr>
+              <a:defRPr sz="3000" b="1">
+                <a:solidFill>
+                  <a:srgbClr val="1E262C"/>
+                </a:solidFill>
+              </a:defRPr>
+            </a:pPr>
+            <a:r>
+              <a:t>Results: Smoother Replay Contact</a:t>
+            </a:r>
+          </a:p>
+        </p:txBody>
+      </p:sp>
+      <p:sp>
+        <p:nvSpPr>
+          <p:cNvPr id="4" name="TextBox 3"/>
+          <p:cNvSpPr txBox="1"/>
+          <p:nvPr/>
+        </p:nvSpPr>
+        <p:spPr>
+          <a:xfrm>
+            <a:off x="530352" y="960120"/>
+            <a:ext cx="10515600" cy="347472"/>
+          </a:xfrm>
+          <a:prstGeom prst="rect">
+            <a:avLst/>
+          </a:prstGeom>
+          <a:noFill/>
+        </p:spPr>
+        <p:txBody>
+          <a:bodyPr wrap="square" lIns="18288" rIns="18288">
+            <a:spAutoFit/>
+          </a:bodyPr>
+          <a:lstStyle/>
+          <a:p>
+            <a:pPr>
+              <a:defRPr sz="1300" b="0">
+                <a:solidFill>
+                  <a:srgbClr val="5B6770"/>
+                </a:solidFill>
+              </a:defRPr>
+            </a:pPr>
+            <a:r>
+              <a:t>New output: foul_bodypart_replay_video_smoother</a:t>
+            </a:r>
+          </a:p>
+        </p:txBody>
+      </p:sp>
+      <p:pic>
+        <p:nvPicPr>
+          <p:cNvPr id="5" name="Picture 4" descr="smoother_action_0_seq_1.jpg"/>
+          <p:cNvPicPr>
+            <a:picLocks noChangeAspect="1"/>
+          </p:cNvPicPr>
+          <p:nvPr/>
+        </p:nvPicPr>
+        <p:blipFill>
+          <a:blip r:embed="rId2"/>
+          <a:stretch>
+            <a:fillRect/>
+          </a:stretch>
+        </p:blipFill>
+        <p:spPr>
+          <a:xfrm>
+            <a:off x="594360" y="2109120"/>
+            <a:ext cx="2660904" cy="1496758"/>
+          </a:xfrm>
+          <a:prstGeom prst="rect">
+            <a:avLst/>
+          </a:prstGeom>
+          <a:ln w="12700">
+            <a:solidFill>
+              <a:srgbClr val="DAE0DB"/>
+            </a:solidFill>
+          </a:ln>
+        </p:spPr>
+      </p:pic>
+      <p:sp>
+        <p:nvSpPr>
+          <p:cNvPr id="6" name="TextBox 5"/>
+          <p:cNvSpPr txBox="1"/>
+          <p:nvPr/>
+        </p:nvSpPr>
+        <p:spPr>
+          <a:xfrm>
+            <a:off x="594360" y="4389120"/>
+            <a:ext cx="2660904" cy="228600"/>
+          </a:xfrm>
+          <a:prstGeom prst="rect">
+            <a:avLst/>
+          </a:prstGeom>
+          <a:noFill/>
+        </p:spPr>
+        <p:txBody>
+          <a:bodyPr wrap="square" lIns="18288" rIns="18288">
+            <a:spAutoFit/>
+          </a:bodyPr>
+          <a:lstStyle/>
+          <a:p>
+            <a:pPr algn="ctr">
+              <a:defRPr sz="1000" b="0">
+                <a:solidFill>
+                  <a:srgbClr val="5B6770"/>
+                </a:solidFill>
+              </a:defRPr>
+            </a:pPr>
+            <a:r>
+              <a:t>before replay contact</a:t>
+            </a:r>
+          </a:p>
+        </p:txBody>
+      </p:sp>
+      <p:pic>
+        <p:nvPicPr>
+          <p:cNvPr id="7" name="Picture 6" descr="smoother_action_0_seq_2.jpg"/>
+          <p:cNvPicPr>
+            <a:picLocks noChangeAspect="1"/>
+          </p:cNvPicPr>
+          <p:nvPr/>
+        </p:nvPicPr>
+        <p:blipFill>
+          <a:blip r:embed="rId3"/>
+          <a:stretch>
+            <a:fillRect/>
+          </a:stretch>
+        </p:blipFill>
+        <p:spPr>
+          <a:xfrm>
+            <a:off x="3364992" y="2109120"/>
+            <a:ext cx="2660904" cy="1496758"/>
+          </a:xfrm>
+          <a:prstGeom prst="rect">
+            <a:avLst/>
+          </a:prstGeom>
+          <a:ln w="12700">
+            <a:solidFill>
+              <a:srgbClr val="DAE0DB"/>
+            </a:solidFill>
+          </a:ln>
+        </p:spPr>
+      </p:pic>
+      <p:sp>
+        <p:nvSpPr>
+          <p:cNvPr id="8" name="TextBox 7"/>
+          <p:cNvSpPr txBox="1"/>
+          <p:nvPr/>
+        </p:nvSpPr>
+        <p:spPr>
+          <a:xfrm>
+            <a:off x="3364992" y="4389120"/>
+            <a:ext cx="2660904" cy="228600"/>
+          </a:xfrm>
+          <a:prstGeom prst="rect">
+            <a:avLst/>
+          </a:prstGeom>
+          <a:noFill/>
+        </p:spPr>
+        <p:txBody>
+          <a:bodyPr wrap="square" lIns="18288" rIns="18288">
+            <a:spAutoFit/>
+          </a:bodyPr>
+          <a:lstStyle/>
+          <a:p>
+            <a:pPr algn="ctr">
+              <a:defRPr sz="1000" b="0">
+                <a:solidFill>
+                  <a:srgbClr val="5B6770"/>
+                </a:solidFill>
+              </a:defRPr>
+            </a:pPr>
+            <a:r>
+              <a:t>players converge</a:t>
+            </a:r>
+          </a:p>
+        </p:txBody>
+      </p:sp>
+      <p:pic>
+        <p:nvPicPr>
+          <p:cNvPr id="9" name="Picture 8" descr="smoother_action_0_seq_3.jpg"/>
+          <p:cNvPicPr>
+            <a:picLocks noChangeAspect="1"/>
+          </p:cNvPicPr>
+          <p:nvPr/>
+        </p:nvPicPr>
+        <p:blipFill>
+          <a:blip r:embed="rId4"/>
+          <a:stretch>
+            <a:fillRect/>
+          </a:stretch>
+        </p:blipFill>
+        <p:spPr>
+          <a:xfrm>
+            <a:off x="6135624" y="2109120"/>
+            <a:ext cx="2660904" cy="1496758"/>
+          </a:xfrm>
+          <a:prstGeom prst="rect">
+            <a:avLst/>
+          </a:prstGeom>
+          <a:ln w="12700">
+            <a:solidFill>
+              <a:srgbClr val="DAE0DB"/>
+            </a:solidFill>
+          </a:ln>
+        </p:spPr>
+      </p:pic>
+      <p:sp>
+        <p:nvSpPr>
+          <p:cNvPr id="10" name="TextBox 9"/>
+          <p:cNvSpPr txBox="1"/>
+          <p:nvPr/>
+        </p:nvSpPr>
+        <p:spPr>
+          <a:xfrm>
+            <a:off x="6135624" y="4389120"/>
+            <a:ext cx="2660904" cy="228600"/>
+          </a:xfrm>
+          <a:prstGeom prst="rect">
+            <a:avLst/>
+          </a:prstGeom>
+          <a:noFill/>
+        </p:spPr>
+        <p:txBody>
+          <a:bodyPr wrap="square" lIns="18288" rIns="18288">
+            <a:spAutoFit/>
+          </a:bodyPr>
+          <a:lstStyle/>
+          <a:p>
+            <a:pPr algn="ctr">
+              <a:defRPr sz="1000" b="0">
+                <a:solidFill>
+                  <a:srgbClr val="5B6770"/>
+                </a:solidFill>
+              </a:defRPr>
+            </a:pPr>
+            <a:r>
+              <a:t>contact frame 24</a:t>
+            </a:r>
+          </a:p>
+        </p:txBody>
+      </p:sp>
+      <p:pic>
+        <p:nvPicPr>
+          <p:cNvPr id="11" name="Picture 10" descr="smoother_action_0_seq_4.jpg"/>
+          <p:cNvPicPr>
+            <a:picLocks noChangeAspect="1"/>
+          </p:cNvPicPr>
+          <p:nvPr/>
+        </p:nvPicPr>
+        <p:blipFill>
+          <a:blip r:embed="rId5"/>
+          <a:stretch>
+            <a:fillRect/>
+          </a:stretch>
+        </p:blipFill>
+        <p:spPr>
+          <a:xfrm>
+            <a:off x="8906256" y="2109120"/>
+            <a:ext cx="2660904" cy="1496758"/>
+          </a:xfrm>
+          <a:prstGeom prst="rect">
+            <a:avLst/>
+          </a:prstGeom>
+          <a:ln w="12700">
+            <a:solidFill>
+              <a:srgbClr val="DAE0DB"/>
+            </a:solidFill>
+          </a:ln>
+        </p:spPr>
+      </p:pic>
+      <p:sp>
+        <p:nvSpPr>
+          <p:cNvPr id="12" name="TextBox 11"/>
+          <p:cNvSpPr txBox="1"/>
+          <p:nvPr/>
+        </p:nvSpPr>
+        <p:spPr>
+          <a:xfrm>
+            <a:off x="8906256" y="4389120"/>
+            <a:ext cx="2660904" cy="228600"/>
+          </a:xfrm>
+          <a:prstGeom prst="rect">
+            <a:avLst/>
+          </a:prstGeom>
+          <a:noFill/>
+        </p:spPr>
+        <p:txBody>
+          <a:bodyPr wrap="square" lIns="18288" rIns="18288">
+            <a:spAutoFit/>
+          </a:bodyPr>
+          <a:lstStyle/>
+          <a:p>
+            <a:pPr algn="ctr">
+              <a:defRPr sz="1000" b="0">
+                <a:solidFill>
+                  <a:srgbClr val="5B6770"/>
+                </a:solidFill>
+              </a:defRPr>
+            </a:pPr>
+            <a:r>
+              <a:t>overlay continues smoothly</a:t>
+            </a:r>
+          </a:p>
+        </p:txBody>
+      </p:sp>
+      <p:sp>
+        <p:nvSpPr>
+          <p:cNvPr id="13" name="TextBox 12"/>
+          <p:cNvSpPr txBox="1"/>
+          <p:nvPr/>
+        </p:nvSpPr>
+        <p:spPr>
+          <a:xfrm>
+            <a:off x="822960" y="4892040"/>
+            <a:ext cx="6766560" cy="914400"/>
+          </a:xfrm>
+          <a:prstGeom prst="rect">
+            <a:avLst/>
+          </a:prstGeom>
+          <a:noFill/>
+        </p:spPr>
+        <p:txBody>
+          <a:bodyPr wrap="square">
+            <a:spAutoFit/>
+          </a:bodyPr>
+          <a:lstStyle/>
+          <a:p>
+            <a:pPr>
+              <a:spcAft>
+                <a:spcPts val="700"/>
+              </a:spcAft>
+              <a:defRPr sz="1500">
+                <a:solidFill>
+                  <a:srgbClr val="1E262C"/>
+                </a:solidFill>
+              </a:defRPr>
+            </a:pPr>
+            <a:r>
+              <a:t>Action 0 selected replay, close-up view (Close-up player or field referee).</a:t>
+            </a:r>
+          </a:p>
+          <a:p>
+            <a:pPr>
+              <a:spcAft>
+                <a:spcPts val="700"/>
+              </a:spcAft>
+              <a:defRPr sz="1500">
+                <a:solidFill>
+                  <a:srgbClr val="1E262C"/>
+                </a:solidFill>
+              </a:defRPr>
+            </a:pPr>
+            <a:r>
+              <a:t>Deep prediction: Offence, severity 1.0, action Holding.</a:t>
+            </a:r>
+          </a:p>
+          <a:p>
+            <a:pPr>
+              <a:spcAft>
+                <a:spcPts val="700"/>
+              </a:spcAft>
+              <a:defRPr sz="1500">
+                <a:solidFill>
+                  <a:srgbClr val="1E262C"/>
+                </a:solidFill>
+              </a:defRPr>
+            </a:pPr>
+            <a:r>
+              <a:t>Pose contact maps the red box to arm / Upper body with 8 players detected.</a:t>
+            </a:r>
+          </a:p>
+        </p:txBody>
+      </p:sp>
+      <p:sp>
+        <p:nvSpPr>
+          <p:cNvPr id="14" name="Rectangle 13"/>
+          <p:cNvSpPr/>
+          <p:nvPr/>
+        </p:nvSpPr>
+        <p:spPr>
+          <a:xfrm>
+            <a:off x="7909560" y="4709160"/>
+            <a:ext cx="3383280" cy="1143000"/>
+          </a:xfrm>
+          <a:prstGeom prst="rect">
+            <a:avLst/>
+          </a:prstGeom>
+          <a:solidFill>
+            <a:srgbClr val="FFFFFF"/>
+          </a:solidFill>
+          <a:ln>
+            <a:solidFill>
+              <a:srgbClr val="E6EBE5"/>
+            </a:solidFill>
+          </a:ln>
+        </p:spPr>
+        <p:style>
+          <a:lnRef idx="1">
+            <a:schemeClr val="accent1"/>
+          </a:lnRef>
+          <a:fillRef idx="3">
+            <a:schemeClr val="accent1"/>
+          </a:fillRef>
+          <a:effectRef idx="2">
+            <a:schemeClr val="accent1"/>
+          </a:effectRef>
+          <a:fontRef idx="minor">
+            <a:schemeClr val="lt1"/>
+          </a:fontRef>
+        </p:style>
+        <p:txBody>
+          <a:bodyPr rtlCol="0" anchor="ctr"/>
+          <a:lstStyle/>
+          <a:p>
+            <a:pPr algn="ctr"/>
+          </a:p>
+        </p:txBody>
+      </p:sp>
+      <p:sp>
+        <p:nvSpPr>
+          <p:cNvPr id="15" name="Rectangle 14"/>
+          <p:cNvSpPr/>
+          <p:nvPr/>
+        </p:nvSpPr>
+        <p:spPr>
+          <a:xfrm>
+            <a:off x="7909560" y="4709160"/>
+            <a:ext cx="73152" cy="1143000"/>
+          </a:xfrm>
+          <a:prstGeom prst="rect">
+            <a:avLst/>
+          </a:prstGeom>
+          <a:solidFill>
+            <a:srgbClr val="C2272D"/>
+          </a:solidFill>
+          <a:ln>
+            <a:solidFill>
+              <a:srgbClr val="C2272D"/>
+            </a:solidFill>
+          </a:ln>
+        </p:spPr>
+        <p:style>
+          <a:lnRef idx="1">
+            <a:schemeClr val="accent1"/>
+          </a:lnRef>
+          <a:fillRef idx="3">
+            <a:schemeClr val="accent1"/>
+          </a:fillRef>
+          <a:effectRef idx="2">
+            <a:schemeClr val="accent1"/>
+          </a:effectRef>
+          <a:fontRef idx="minor">
+            <a:schemeClr val="lt1"/>
+          </a:fontRef>
+        </p:style>
+        <p:txBody>
+          <a:bodyPr rtlCol="0" anchor="ctr"/>
+          <a:lstStyle/>
+          <a:p>
+            <a:pPr algn="ctr"/>
+          </a:p>
+        </p:txBody>
+      </p:sp>
+      <p:sp>
+        <p:nvSpPr>
+          <p:cNvPr id="16" name="TextBox 15"/>
+          <p:cNvSpPr txBox="1"/>
+          <p:nvPr/>
+        </p:nvSpPr>
+        <p:spPr>
+          <a:xfrm>
+            <a:off x="8138160" y="4873752"/>
+            <a:ext cx="2971800" cy="320040"/>
+          </a:xfrm>
+          <a:prstGeom prst="rect">
+            <a:avLst/>
+          </a:prstGeom>
+          <a:noFill/>
+        </p:spPr>
+        <p:txBody>
+          <a:bodyPr wrap="square" lIns="18288" rIns="18288">
+            <a:spAutoFit/>
+          </a:bodyPr>
+          <a:lstStyle/>
+          <a:p>
+            <a:pPr>
+              <a:defRPr sz="1500" b="1">
+                <a:solidFill>
+                  <a:srgbClr val="C2272D"/>
+                </a:solidFill>
+              </a:defRPr>
+            </a:pPr>
+            <a:r>
+              <a:t>Why it helps</a:t>
+            </a:r>
+          </a:p>
+        </p:txBody>
+      </p:sp>
+      <p:sp>
+        <p:nvSpPr>
+          <p:cNvPr id="17" name="TextBox 16"/>
+          <p:cNvSpPr txBox="1"/>
+          <p:nvPr/>
+        </p:nvSpPr>
+        <p:spPr>
+          <a:xfrm>
+            <a:off x="8138160" y="5294376"/>
+            <a:ext cx="2971800" cy="457200"/>
+          </a:xfrm>
+          <a:prstGeom prst="rect">
+            <a:avLst/>
+          </a:prstGeom>
+          <a:noFill/>
+        </p:spPr>
+        <p:txBody>
+          <a:bodyPr wrap="square" lIns="18288" rIns="18288">
+            <a:spAutoFit/>
+          </a:bodyPr>
+          <a:lstStyle/>
+          <a:p>
+            <a:pPr>
+              <a:defRPr sz="1400" b="0">
+                <a:solidFill>
+                  <a:srgbClr val="1E262C"/>
+                </a:solidFill>
+              </a:defRPr>
+            </a:pPr>
+            <a:r>
+              <a:t>The replay/close-up view makes the contact box easier to inspect than the broadcast-wide live view.</a:t>
+            </a:r>
+          </a:p>
+        </p:txBody>
+      </p:sp>
+      <p:sp>
+        <p:nvSpPr>
+          <p:cNvPr id="18" name="TextBox 17"/>
+          <p:cNvSpPr txBox="1"/>
+          <p:nvPr/>
+        </p:nvSpPr>
+        <p:spPr>
+          <a:xfrm>
+            <a:off x="10789920" y="6446520"/>
+            <a:ext cx="914400" cy="228600"/>
+          </a:xfrm>
+          <a:prstGeom prst="rect">
+            <a:avLst/>
+          </a:prstGeom>
+          <a:noFill/>
+        </p:spPr>
+        <p:txBody>
+          <a:bodyPr wrap="square" lIns="18288" rIns="18288">
+            <a:spAutoFit/>
+          </a:bodyPr>
+          <a:lstStyle/>
+          <a:p>
+            <a:pPr algn="r">
+              <a:defRPr sz="900" b="0">
+                <a:solidFill>
+                  <a:srgbClr val="5B6770"/>
+                </a:solidFill>
+              </a:defRPr>
+            </a:pPr>
+            <a:r>
+              <a:t>12</a:t>
+            </a:r>
+          </a:p>
+        </p:txBody>
+      </p:sp>
+    </p:spTree>
+  </p:cSld>
+  <p:clrMapOvr>
+    <a:masterClrMapping/>
+  </p:clrMapOvr>
+</p:sld>
+</file>
+
+<file path=ppt/slides/slide13.xml><?xml version="1.0" encoding="utf-8"?>
+<p:sld xmlns:a="http://schemas.openxmlformats.org/drawingml/2006/main" xmlns:p="http://schemas.openxmlformats.org/presentationml/2006/main" xmlns:r="http://schemas.openxmlformats.org/officeDocument/2006/relationships">
+  <p:cSld>
+    <p:bg>
+      <p:bgPr>
+        <a:solidFill>
+          <a:srgbClr val="F6F7F3"/>
+        </a:solidFill>
+        <a:effectLst/>
+      </p:bgPr>
+    </p:bg>
+    <p:spTree>
+      <p:nvGrpSpPr>
+        <p:cNvPr id="1" name=""/>
+        <p:cNvGrpSpPr/>
+        <p:nvPr/>
+      </p:nvGrpSpPr>
+      <p:grpSpPr/>
+      <p:sp>
+        <p:nvSpPr>
+          <p:cNvPr id="2" name="Rectangle 1"/>
+          <p:cNvSpPr/>
+          <p:nvPr/>
+        </p:nvSpPr>
+        <p:spPr>
+          <a:xfrm>
+            <a:off x="0" y="0"/>
+            <a:ext cx="164592" cy="6858000"/>
+          </a:xfrm>
+          <a:prstGeom prst="rect">
+            <a:avLst/>
+          </a:prstGeom>
+          <a:solidFill>
+            <a:srgbClr val="C2272D"/>
+          </a:solidFill>
+          <a:ln>
+            <a:solidFill>
+              <a:srgbClr val="C2272D"/>
+            </a:solidFill>
+          </a:ln>
+        </p:spPr>
+        <p:style>
+          <a:lnRef idx="1">
+            <a:schemeClr val="accent1"/>
+          </a:lnRef>
+          <a:fillRef idx="3">
+            <a:schemeClr val="accent1"/>
+          </a:fillRef>
+          <a:effectRef idx="2">
+            <a:schemeClr val="accent1"/>
+          </a:effectRef>
+          <a:fontRef idx="minor">
+            <a:schemeClr val="lt1"/>
+          </a:fontRef>
+        </p:style>
+        <p:txBody>
+          <a:bodyPr rtlCol="0" anchor="ctr"/>
+          <a:lstStyle/>
+          <a:p>
+            <a:pPr algn="ctr"/>
+          </a:p>
+        </p:txBody>
+      </p:sp>
+      <p:sp>
+        <p:nvSpPr>
+          <p:cNvPr id="3" name="TextBox 2"/>
+          <p:cNvSpPr txBox="1"/>
+          <p:nvPr/>
+        </p:nvSpPr>
+        <p:spPr>
+          <a:xfrm>
+            <a:off x="502920" y="320040"/>
+            <a:ext cx="10972800" cy="658368"/>
+          </a:xfrm>
+          <a:prstGeom prst="rect">
+            <a:avLst/>
+          </a:prstGeom>
+          <a:noFill/>
+        </p:spPr>
+        <p:txBody>
+          <a:bodyPr wrap="square" lIns="18288" rIns="18288">
+            <a:spAutoFit/>
+          </a:bodyPr>
+          <a:lstStyle/>
+          <a:p>
+            <a:pPr>
+              <a:defRPr sz="3000" b="1">
+                <a:solidFill>
+                  <a:srgbClr val="1E262C"/>
+                </a:solidFill>
+              </a:defRPr>
+            </a:pPr>
+            <a:r>
+              <a:t>Results: Body-Part Replay Summary</a:t>
+            </a:r>
+          </a:p>
+        </p:txBody>
+      </p:sp>
+      <p:sp>
+        <p:nvSpPr>
+          <p:cNvPr id="4" name="TextBox 3"/>
+          <p:cNvSpPr txBox="1"/>
+          <p:nvPr/>
+        </p:nvSpPr>
+        <p:spPr>
+          <a:xfrm>
+            <a:off x="530352" y="960120"/>
+            <a:ext cx="10515600" cy="347472"/>
+          </a:xfrm>
+          <a:prstGeom prst="rect">
+            <a:avLst/>
+          </a:prstGeom>
+          <a:noFill/>
+        </p:spPr>
+        <p:txBody>
+          <a:bodyPr wrap="square" lIns="18288" rIns="18288">
+            <a:spAutoFit/>
+          </a:bodyPr>
+          <a:lstStyle/>
+          <a:p>
+            <a:pPr>
+              <a:defRPr sz="1300" b="0">
+                <a:solidFill>
+                  <a:srgbClr val="5B6770"/>
+                </a:solidFill>
+              </a:defRPr>
+            </a:pPr>
+            <a:r>
+              <a:t>Five validation replay/close-up examples with smoother foul overlays</a:t>
+            </a:r>
+          </a:p>
+        </p:txBody>
+      </p:sp>
+      <p:pic>
+        <p:nvPicPr>
+          <p:cNvPr id="5" name="Picture 4" descr="contact_bodypart.png"/>
+          <p:cNvPicPr>
+            <a:picLocks noChangeAspect="1"/>
+          </p:cNvPicPr>
+          <p:nvPr/>
+        </p:nvPicPr>
+        <p:blipFill>
+          <a:blip r:embed="rId2"/>
+          <a:stretch>
+            <a:fillRect/>
+          </a:stretch>
+        </p:blipFill>
+        <p:spPr>
+          <a:xfrm>
+            <a:off x="566928" y="1430178"/>
+            <a:ext cx="2148840" cy="1208722"/>
+          </a:xfrm>
+          <a:prstGeom prst="rect">
+            <a:avLst/>
+          </a:prstGeom>
+          <a:ln w="12700">
+            <a:solidFill>
+              <a:srgbClr val="DAE0DB"/>
+            </a:solidFill>
+          </a:ln>
+        </p:spPr>
+      </p:pic>
+      <p:sp>
+        <p:nvSpPr>
+          <p:cNvPr id="6" name="TextBox 5"/>
+          <p:cNvSpPr txBox="1"/>
+          <p:nvPr/>
+        </p:nvSpPr>
+        <p:spPr>
+          <a:xfrm>
+            <a:off x="566928" y="2779776"/>
+            <a:ext cx="2148840" cy="219456"/>
+          </a:xfrm>
+          <a:prstGeom prst="rect">
+            <a:avLst/>
+          </a:prstGeom>
+          <a:noFill/>
+        </p:spPr>
+        <p:txBody>
+          <a:bodyPr wrap="square" lIns="18288" rIns="18288">
+            <a:spAutoFit/>
+          </a:bodyPr>
+          <a:lstStyle/>
+          <a:p>
+            <a:pPr algn="ctr">
+              <a:defRPr sz="1000" b="0">
+                <a:solidFill>
+                  <a:srgbClr val="5B6770"/>
+                </a:solidFill>
+              </a:defRPr>
+            </a:pPr>
+            <a:r>
+              <a:t>A0: arm</a:t>
+            </a:r>
+          </a:p>
+        </p:txBody>
+      </p:sp>
+      <p:pic>
+        <p:nvPicPr>
+          <p:cNvPr id="7" name="Picture 6" descr="contact_bodypart.png"/>
+          <p:cNvPicPr>
+            <a:picLocks noChangeAspect="1"/>
+          </p:cNvPicPr>
+          <p:nvPr/>
+        </p:nvPicPr>
+        <p:blipFill>
+          <a:blip r:embed="rId3"/>
+          <a:stretch>
+            <a:fillRect/>
+          </a:stretch>
+        </p:blipFill>
+        <p:spPr>
+          <a:xfrm>
+            <a:off x="2825496" y="1430178"/>
+            <a:ext cx="2148840" cy="1208722"/>
+          </a:xfrm>
+          <a:prstGeom prst="rect">
+            <a:avLst/>
+          </a:prstGeom>
+          <a:ln w="12700">
+            <a:solidFill>
+              <a:srgbClr val="DAE0DB"/>
+            </a:solidFill>
+          </a:ln>
+        </p:spPr>
+      </p:pic>
+      <p:sp>
+        <p:nvSpPr>
+          <p:cNvPr id="8" name="TextBox 7"/>
+          <p:cNvSpPr txBox="1"/>
+          <p:nvPr/>
+        </p:nvSpPr>
+        <p:spPr>
+          <a:xfrm>
+            <a:off x="2825496" y="2779776"/>
+            <a:ext cx="2148840" cy="219456"/>
+          </a:xfrm>
+          <a:prstGeom prst="rect">
+            <a:avLst/>
+          </a:prstGeom>
+          <a:noFill/>
+        </p:spPr>
+        <p:txBody>
+          <a:bodyPr wrap="square" lIns="18288" rIns="18288">
+            <a:spAutoFit/>
+          </a:bodyPr>
+          <a:lstStyle/>
+          <a:p>
+            <a:pPr algn="ctr">
+              <a:defRPr sz="1000" b="0">
+                <a:solidFill>
+                  <a:srgbClr val="5B6770"/>
+                </a:solidFill>
+              </a:defRPr>
+            </a:pPr>
+            <a:r>
+              <a:t>A3: back/torso</a:t>
+            </a:r>
+          </a:p>
+        </p:txBody>
+      </p:sp>
+      <p:pic>
+        <p:nvPicPr>
+          <p:cNvPr id="9" name="Picture 8" descr="contact_bodypart.png"/>
+          <p:cNvPicPr>
+            <a:picLocks noChangeAspect="1"/>
+          </p:cNvPicPr>
+          <p:nvPr/>
+        </p:nvPicPr>
+        <p:blipFill>
+          <a:blip r:embed="rId4"/>
+          <a:stretch>
+            <a:fillRect/>
+          </a:stretch>
+        </p:blipFill>
+        <p:spPr>
+          <a:xfrm>
+            <a:off x="5084064" y="1430178"/>
+            <a:ext cx="2148840" cy="1208722"/>
+          </a:xfrm>
+          <a:prstGeom prst="rect">
+            <a:avLst/>
+          </a:prstGeom>
+          <a:ln w="12700">
+            <a:solidFill>
+              <a:srgbClr val="DAE0DB"/>
+            </a:solidFill>
+          </a:ln>
+        </p:spPr>
+      </p:pic>
+      <p:sp>
+        <p:nvSpPr>
+          <p:cNvPr id="10" name="TextBox 9"/>
+          <p:cNvSpPr txBox="1"/>
+          <p:nvPr/>
+        </p:nvSpPr>
+        <p:spPr>
+          <a:xfrm>
+            <a:off x="5084064" y="2779776"/>
+            <a:ext cx="2148840" cy="219456"/>
+          </a:xfrm>
+          <a:prstGeom prst="rect">
+            <a:avLst/>
+          </a:prstGeom>
+          <a:noFill/>
+        </p:spPr>
+        <p:txBody>
+          <a:bodyPr wrap="square" lIns="18288" rIns="18288">
+            <a:spAutoFit/>
+          </a:bodyPr>
+          <a:lstStyle/>
+          <a:p>
+            <a:pPr algn="ctr">
+              <a:defRPr sz="1000" b="0">
+                <a:solidFill>
+                  <a:srgbClr val="5B6770"/>
+                </a:solidFill>
+              </a:defRPr>
+            </a:pPr>
+            <a:r>
+              <a:t>A8: arm</a:t>
+            </a:r>
+          </a:p>
+        </p:txBody>
+      </p:sp>
+      <p:pic>
+        <p:nvPicPr>
+          <p:cNvPr id="11" name="Picture 10" descr="contact_bodypart.png"/>
+          <p:cNvPicPr>
+            <a:picLocks noChangeAspect="1"/>
+          </p:cNvPicPr>
+          <p:nvPr/>
+        </p:nvPicPr>
+        <p:blipFill>
+          <a:blip r:embed="rId5"/>
+          <a:stretch>
+            <a:fillRect/>
+          </a:stretch>
+        </p:blipFill>
+        <p:spPr>
+          <a:xfrm>
+            <a:off x="7342631" y="1430178"/>
+            <a:ext cx="2148840" cy="1208722"/>
+          </a:xfrm>
+          <a:prstGeom prst="rect">
+            <a:avLst/>
+          </a:prstGeom>
+          <a:ln w="12700">
+            <a:solidFill>
+              <a:srgbClr val="DAE0DB"/>
+            </a:solidFill>
+          </a:ln>
+        </p:spPr>
+      </p:pic>
+      <p:sp>
+        <p:nvSpPr>
+          <p:cNvPr id="12" name="TextBox 11"/>
+          <p:cNvSpPr txBox="1"/>
+          <p:nvPr/>
+        </p:nvSpPr>
+        <p:spPr>
+          <a:xfrm>
+            <a:off x="7342631" y="2779776"/>
+            <a:ext cx="2148840" cy="219456"/>
+          </a:xfrm>
+          <a:prstGeom prst="rect">
+            <a:avLst/>
+          </a:prstGeom>
+          <a:noFill/>
+        </p:spPr>
+        <p:txBody>
+          <a:bodyPr wrap="square" lIns="18288" rIns="18288">
+            <a:spAutoFit/>
+          </a:bodyPr>
+          <a:lstStyle/>
+          <a:p>
+            <a:pPr algn="ctr">
+              <a:defRPr sz="1000" b="0">
+                <a:solidFill>
+                  <a:srgbClr val="5B6770"/>
+                </a:solidFill>
+              </a:defRPr>
+            </a:pPr>
+            <a:r>
+              <a:t>A10: arm</a:t>
+            </a:r>
+          </a:p>
+        </p:txBody>
+      </p:sp>
+      <p:pic>
+        <p:nvPicPr>
+          <p:cNvPr id="13" name="Picture 12" descr="contact_bodypart.png"/>
+          <p:cNvPicPr>
+            <a:picLocks noChangeAspect="1"/>
+          </p:cNvPicPr>
+          <p:nvPr/>
+        </p:nvPicPr>
+        <p:blipFill>
+          <a:blip r:embed="rId6"/>
+          <a:stretch>
+            <a:fillRect/>
+          </a:stretch>
+        </p:blipFill>
+        <p:spPr>
+          <a:xfrm>
+            <a:off x="9601200" y="1430178"/>
+            <a:ext cx="2148840" cy="1208722"/>
+          </a:xfrm>
+          <a:prstGeom prst="rect">
+            <a:avLst/>
+          </a:prstGeom>
+          <a:ln w="12700">
+            <a:solidFill>
+              <a:srgbClr val="DAE0DB"/>
+            </a:solidFill>
+          </a:ln>
+        </p:spPr>
+      </p:pic>
+      <p:sp>
+        <p:nvSpPr>
+          <p:cNvPr id="14" name="TextBox 13"/>
+          <p:cNvSpPr txBox="1"/>
+          <p:nvPr/>
+        </p:nvSpPr>
+        <p:spPr>
+          <a:xfrm>
+            <a:off x="9601200" y="2779776"/>
+            <a:ext cx="2148840" cy="219456"/>
+          </a:xfrm>
+          <a:prstGeom prst="rect">
+            <a:avLst/>
+          </a:prstGeom>
+          <a:noFill/>
+        </p:spPr>
+        <p:txBody>
+          <a:bodyPr wrap="square" lIns="18288" rIns="18288">
+            <a:spAutoFit/>
+          </a:bodyPr>
+          <a:lstStyle/>
+          <a:p>
+            <a:pPr algn="ctr">
+              <a:defRPr sz="1000" b="0">
+                <a:solidFill>
+                  <a:srgbClr val="5B6770"/>
+                </a:solidFill>
+              </a:defRPr>
+            </a:pPr>
+            <a:r>
+              <a:t>A12: arm</a:t>
+            </a:r>
+          </a:p>
+        </p:txBody>
+      </p:sp>
+      <p:sp>
+        <p:nvSpPr>
+          <p:cNvPr id="15" name="Rectangle 14"/>
+          <p:cNvSpPr/>
+          <p:nvPr/>
+        </p:nvSpPr>
+        <p:spPr>
+          <a:xfrm>
+            <a:off x="685800" y="3657600"/>
+            <a:ext cx="3337560" cy="1874519"/>
+          </a:xfrm>
+          <a:prstGeom prst="rect">
+            <a:avLst/>
+          </a:prstGeom>
+          <a:solidFill>
+            <a:srgbClr val="FFFFFF"/>
+          </a:solidFill>
+          <a:ln>
+            <a:solidFill>
+              <a:srgbClr val="E6EBE5"/>
+            </a:solidFill>
+          </a:ln>
+        </p:spPr>
+        <p:style>
+          <a:lnRef idx="1">
+            <a:schemeClr val="accent1"/>
+          </a:lnRef>
+          <a:fillRef idx="3">
+            <a:schemeClr val="accent1"/>
+          </a:fillRef>
+          <a:effectRef idx="2">
+            <a:schemeClr val="accent1"/>
+          </a:effectRef>
+          <a:fontRef idx="minor">
+            <a:schemeClr val="lt1"/>
+          </a:fontRef>
+        </p:style>
+        <p:txBody>
+          <a:bodyPr rtlCol="0" anchor="ctr"/>
+          <a:lstStyle/>
+          <a:p>
+            <a:pPr algn="ctr"/>
+          </a:p>
+        </p:txBody>
+      </p:sp>
+      <p:sp>
+        <p:nvSpPr>
+          <p:cNvPr id="16" name="Rectangle 15"/>
+          <p:cNvSpPr/>
+          <p:nvPr/>
+        </p:nvSpPr>
+        <p:spPr>
+          <a:xfrm>
+            <a:off x="685800" y="3657600"/>
+            <a:ext cx="73152" cy="1874519"/>
+          </a:xfrm>
+          <a:prstGeom prst="rect">
+            <a:avLst/>
+          </a:prstGeom>
+          <a:solidFill>
+            <a:srgbClr val="255B8E"/>
+          </a:solidFill>
+          <a:ln>
+            <a:solidFill>
+              <a:srgbClr val="255B8E"/>
+            </a:solidFill>
+          </a:ln>
+        </p:spPr>
+        <p:style>
+          <a:lnRef idx="1">
+            <a:schemeClr val="accent1"/>
+          </a:lnRef>
+          <a:fillRef idx="3">
+            <a:schemeClr val="accent1"/>
+          </a:fillRef>
+          <a:effectRef idx="2">
+            <a:schemeClr val="accent1"/>
+          </a:effectRef>
+          <a:fontRef idx="minor">
+            <a:schemeClr val="lt1"/>
+          </a:fontRef>
+        </p:style>
+        <p:txBody>
+          <a:bodyPr rtlCol="0" anchor="ctr"/>
+          <a:lstStyle/>
+          <a:p>
+            <a:pPr algn="ctr"/>
+          </a:p>
+        </p:txBody>
+      </p:sp>
+      <p:sp>
+        <p:nvSpPr>
+          <p:cNvPr id="17" name="TextBox 16"/>
+          <p:cNvSpPr txBox="1"/>
+          <p:nvPr/>
+        </p:nvSpPr>
+        <p:spPr>
+          <a:xfrm>
+            <a:off x="914400" y="3822191"/>
+            <a:ext cx="2926079" cy="320040"/>
+          </a:xfrm>
+          <a:prstGeom prst="rect">
+            <a:avLst/>
+          </a:prstGeom>
+          <a:noFill/>
+        </p:spPr>
+        <p:txBody>
+          <a:bodyPr wrap="square" lIns="18288" rIns="18288">
+            <a:spAutoFit/>
+          </a:bodyPr>
+          <a:lstStyle/>
+          <a:p>
+            <a:pPr>
+              <a:defRPr sz="1500" b="1">
+                <a:solidFill>
+                  <a:srgbClr val="255B8E"/>
+                </a:solidFill>
+              </a:defRPr>
+            </a:pPr>
+            <a:r>
+              <a:t>Pose/CV Body Part</a:t>
+            </a:r>
+          </a:p>
+        </p:txBody>
+      </p:sp>
+      <p:sp>
+        <p:nvSpPr>
+          <p:cNvPr id="18" name="TextBox 17"/>
+          <p:cNvSpPr txBox="1"/>
+          <p:nvPr/>
+        </p:nvSpPr>
+        <p:spPr>
+          <a:xfrm>
+            <a:off x="914400" y="4242816"/>
+            <a:ext cx="2926079" cy="1188719"/>
+          </a:xfrm>
+          <a:prstGeom prst="rect">
+            <a:avLst/>
+          </a:prstGeom>
+          <a:noFill/>
+        </p:spPr>
+        <p:txBody>
+          <a:bodyPr wrap="square" lIns="18288" rIns="18288">
+            <a:spAutoFit/>
+          </a:bodyPr>
+          <a:lstStyle/>
+          <a:p>
+            <a:pPr>
+              <a:defRPr sz="1400" b="0">
+                <a:solidFill>
+                  <a:srgbClr val="1E262C"/>
+                </a:solidFill>
+              </a:defRPr>
+            </a:pPr>
+            <a:r>
+              <a:t>60% coarse accuracy on 5 validation examples. It correctly keeps all Upper-body examples, but misses two Under-body cases as Upper-body.</a:t>
+            </a:r>
+          </a:p>
+        </p:txBody>
+      </p:sp>
+      <p:sp>
+        <p:nvSpPr>
+          <p:cNvPr id="19" name="Rectangle 18"/>
+          <p:cNvSpPr/>
+          <p:nvPr/>
+        </p:nvSpPr>
+        <p:spPr>
+          <a:xfrm>
+            <a:off x="4343400" y="3657600"/>
+            <a:ext cx="3337560" cy="1874519"/>
+          </a:xfrm>
+          <a:prstGeom prst="rect">
+            <a:avLst/>
+          </a:prstGeom>
+          <a:solidFill>
+            <a:srgbClr val="FFFFFF"/>
+          </a:solidFill>
+          <a:ln>
+            <a:solidFill>
+              <a:srgbClr val="E6EBE5"/>
+            </a:solidFill>
+          </a:ln>
+        </p:spPr>
+        <p:style>
+          <a:lnRef idx="1">
+            <a:schemeClr val="accent1"/>
+          </a:lnRef>
+          <a:fillRef idx="3">
+            <a:schemeClr val="accent1"/>
+          </a:fillRef>
+          <a:effectRef idx="2">
+            <a:schemeClr val="accent1"/>
+          </a:effectRef>
+          <a:fontRef idx="minor">
+            <a:schemeClr val="lt1"/>
+          </a:fontRef>
+        </p:style>
+        <p:txBody>
+          <a:bodyPr rtlCol="0" anchor="ctr"/>
+          <a:lstStyle/>
+          <a:p>
+            <a:pPr algn="ctr"/>
+          </a:p>
+        </p:txBody>
+      </p:sp>
+      <p:sp>
+        <p:nvSpPr>
+          <p:cNvPr id="20" name="Rectangle 19"/>
+          <p:cNvSpPr/>
+          <p:nvPr/>
+        </p:nvSpPr>
+        <p:spPr>
+          <a:xfrm>
+            <a:off x="4343400" y="3657600"/>
+            <a:ext cx="73152" cy="1874519"/>
+          </a:xfrm>
+          <a:prstGeom prst="rect">
+            <a:avLst/>
+          </a:prstGeom>
+          <a:solidFill>
+            <a:srgbClr val="297D5D"/>
+          </a:solidFill>
+          <a:ln>
+            <a:solidFill>
+              <a:srgbClr val="297D5D"/>
+            </a:solidFill>
+          </a:ln>
+        </p:spPr>
+        <p:style>
+          <a:lnRef idx="1">
+            <a:schemeClr val="accent1"/>
+          </a:lnRef>
+          <a:fillRef idx="3">
+            <a:schemeClr val="accent1"/>
+          </a:fillRef>
+          <a:effectRef idx="2">
+            <a:schemeClr val="accent1"/>
+          </a:effectRef>
+          <a:fontRef idx="minor">
+            <a:schemeClr val="lt1"/>
+          </a:fontRef>
+        </p:style>
+        <p:txBody>
+          <a:bodyPr rtlCol="0" anchor="ctr"/>
+          <a:lstStyle/>
+          <a:p>
+            <a:pPr algn="ctr"/>
+          </a:p>
+        </p:txBody>
+      </p:sp>
+      <p:sp>
+        <p:nvSpPr>
+          <p:cNvPr id="21" name="TextBox 20"/>
+          <p:cNvSpPr txBox="1"/>
+          <p:nvPr/>
+        </p:nvSpPr>
+        <p:spPr>
+          <a:xfrm>
+            <a:off x="4572000" y="3822191"/>
+            <a:ext cx="2926079" cy="320040"/>
+          </a:xfrm>
+          <a:prstGeom prst="rect">
+            <a:avLst/>
+          </a:prstGeom>
+          <a:noFill/>
+        </p:spPr>
+        <p:txBody>
+          <a:bodyPr wrap="square" lIns="18288" rIns="18288">
+            <a:spAutoFit/>
+          </a:bodyPr>
+          <a:lstStyle/>
+          <a:p>
+            <a:pPr>
+              <a:defRPr sz="1500" b="1">
+                <a:solidFill>
+                  <a:srgbClr val="297D5D"/>
+                </a:solidFill>
+              </a:defRPr>
+            </a:pPr>
+            <a:r>
+              <a:t>Deep Body-Part Head</a:t>
+            </a:r>
+          </a:p>
+        </p:txBody>
+      </p:sp>
+      <p:sp>
+        <p:nvSpPr>
+          <p:cNvPr id="22" name="TextBox 21"/>
+          <p:cNvSpPr txBox="1"/>
+          <p:nvPr/>
+        </p:nvSpPr>
+        <p:spPr>
+          <a:xfrm>
+            <a:off x="4572000" y="4242816"/>
+            <a:ext cx="2926079" cy="1188719"/>
+          </a:xfrm>
+          <a:prstGeom prst="rect">
+            <a:avLst/>
+          </a:prstGeom>
+          <a:noFill/>
+        </p:spPr>
+        <p:txBody>
+          <a:bodyPr wrap="square" lIns="18288" rIns="18288">
+            <a:spAutoFit/>
+          </a:bodyPr>
+          <a:lstStyle/>
+          <a:p>
+            <a:pPr>
+              <a:defRPr sz="1400" b="0">
+                <a:solidFill>
+                  <a:srgbClr val="1E262C"/>
+                </a:solidFill>
+              </a:defRPr>
+            </a:pPr>
+            <a:r>
+              <a:t>80% coarse accuracy on 5 examples. This improves one Under-body case while still showing class imbalance toward Upper-body.</a:t>
+            </a:r>
+          </a:p>
+        </p:txBody>
+      </p:sp>
+      <p:sp>
+        <p:nvSpPr>
+          <p:cNvPr id="23" name="Rectangle 22"/>
+          <p:cNvSpPr/>
+          <p:nvPr/>
+        </p:nvSpPr>
+        <p:spPr>
+          <a:xfrm>
+            <a:off x="8001000" y="3657600"/>
+            <a:ext cx="3337560" cy="1874519"/>
+          </a:xfrm>
+          <a:prstGeom prst="rect">
+            <a:avLst/>
+          </a:prstGeom>
+          <a:solidFill>
+            <a:srgbClr val="FFFFFF"/>
+          </a:solidFill>
+          <a:ln>
+            <a:solidFill>
+              <a:srgbClr val="E6EBE5"/>
+            </a:solidFill>
+          </a:ln>
+        </p:spPr>
+        <p:style>
+          <a:lnRef idx="1">
+            <a:schemeClr val="accent1"/>
+          </a:lnRef>
+          <a:fillRef idx="3">
+            <a:schemeClr val="accent1"/>
+          </a:fillRef>
+          <a:effectRef idx="2">
+            <a:schemeClr val="accent1"/>
+          </a:effectRef>
+          <a:fontRef idx="minor">
+            <a:schemeClr val="lt1"/>
+          </a:fontRef>
+        </p:style>
+        <p:txBody>
+          <a:bodyPr rtlCol="0" anchor="ctr"/>
+          <a:lstStyle/>
+          <a:p>
+            <a:pPr algn="ctr"/>
+          </a:p>
+        </p:txBody>
+      </p:sp>
+      <p:sp>
+        <p:nvSpPr>
+          <p:cNvPr id="24" name="Rectangle 23"/>
+          <p:cNvSpPr/>
+          <p:nvPr/>
+        </p:nvSpPr>
+        <p:spPr>
+          <a:xfrm>
+            <a:off x="8001000" y="3657600"/>
+            <a:ext cx="73152" cy="1874519"/>
+          </a:xfrm>
+          <a:prstGeom prst="rect">
+            <a:avLst/>
+          </a:prstGeom>
+          <a:solidFill>
+            <a:srgbClr val="BD8B31"/>
+          </a:solidFill>
+          <a:ln>
+            <a:solidFill>
+              <a:srgbClr val="BD8B31"/>
+            </a:solidFill>
+          </a:ln>
+        </p:spPr>
+        <p:style>
+          <a:lnRef idx="1">
+            <a:schemeClr val="accent1"/>
+          </a:lnRef>
+          <a:fillRef idx="3">
+            <a:schemeClr val="accent1"/>
+          </a:fillRef>
+          <a:effectRef idx="2">
+            <a:schemeClr val="accent1"/>
+          </a:effectRef>
+          <a:fontRef idx="minor">
+            <a:schemeClr val="lt1"/>
+          </a:fontRef>
+        </p:style>
+        <p:txBody>
+          <a:bodyPr rtlCol="0" anchor="ctr"/>
+          <a:lstStyle/>
+          <a:p>
+            <a:pPr algn="ctr"/>
+          </a:p>
+        </p:txBody>
+      </p:sp>
+      <p:sp>
+        <p:nvSpPr>
+          <p:cNvPr id="25" name="TextBox 24"/>
+          <p:cNvSpPr txBox="1"/>
+          <p:nvPr/>
+        </p:nvSpPr>
+        <p:spPr>
+          <a:xfrm>
+            <a:off x="8229600" y="3822191"/>
+            <a:ext cx="2926079" cy="320040"/>
+          </a:xfrm>
+          <a:prstGeom prst="rect">
+            <a:avLst/>
+          </a:prstGeom>
+          <a:noFill/>
+        </p:spPr>
+        <p:txBody>
+          <a:bodyPr wrap="square" lIns="18288" rIns="18288">
+            <a:spAutoFit/>
+          </a:bodyPr>
+          <a:lstStyle/>
+          <a:p>
+            <a:pPr>
+              <a:defRPr sz="1500" b="1">
+                <a:solidFill>
+                  <a:srgbClr val="BD8B31"/>
+                </a:solidFill>
+              </a:defRPr>
+            </a:pPr>
+            <a:r>
+              <a:t>Current Limitation</a:t>
+            </a:r>
+          </a:p>
+        </p:txBody>
+      </p:sp>
+      <p:sp>
+        <p:nvSpPr>
+          <p:cNvPr id="26" name="TextBox 25"/>
+          <p:cNvSpPr txBox="1"/>
+          <p:nvPr/>
+        </p:nvSpPr>
+        <p:spPr>
+          <a:xfrm>
+            <a:off x="8229600" y="4242816"/>
+            <a:ext cx="2926079" cy="1188719"/>
+          </a:xfrm>
+          <a:prstGeom prst="rect">
+            <a:avLst/>
+          </a:prstGeom>
+          <a:noFill/>
+        </p:spPr>
+        <p:txBody>
+          <a:bodyPr wrap="square" lIns="18288" rIns="18288">
+            <a:spAutoFit/>
+          </a:bodyPr>
+          <a:lstStyle/>
+          <a:p>
+            <a:pPr>
+              <a:defRPr sz="1400" b="0">
+                <a:solidFill>
+                  <a:srgbClr val="1E262C"/>
+                </a:solidFill>
+              </a:defRPr>
+            </a:pPr>
+            <a:r>
+              <a:t>The smoother overlay is visually clearer, but five examples are still too small for a final claim. The next step is full validation/test evaluation.</a:t>
+            </a:r>
+          </a:p>
+        </p:txBody>
+      </p:sp>
+      <p:sp>
+        <p:nvSpPr>
+          <p:cNvPr id="27" name="TextBox 26"/>
+          <p:cNvSpPr txBox="1"/>
+          <p:nvPr/>
+        </p:nvSpPr>
+        <p:spPr>
+          <a:xfrm>
+            <a:off x="10789920" y="6446520"/>
+            <a:ext cx="914400" cy="228600"/>
+          </a:xfrm>
+          <a:prstGeom prst="rect">
+            <a:avLst/>
+          </a:prstGeom>
+          <a:noFill/>
+        </p:spPr>
+        <p:txBody>
+          <a:bodyPr wrap="square" lIns="18288" rIns="18288">
+            <a:spAutoFit/>
+          </a:bodyPr>
+          <a:lstStyle/>
+          <a:p>
+            <a:pPr algn="r">
+              <a:defRPr sz="900" b="0">
+                <a:solidFill>
+                  <a:srgbClr val="5B6770"/>
+                </a:solidFill>
+              </a:defRPr>
+            </a:pPr>
+            <a:r>
+              <a:t>13</a:t>
             </a:r>
           </a:p>
         </p:txBody>

</xml_diff>